<commit_message>
update and sol 1
</commit_message>
<xml_diff>
--- a/slides/02_visual_APC.pptx
+++ b/slides/02_visual_APC.pptx
@@ -218,7 +218,7 @@
           <a:p>
             <a:fld id="{CE43C900-4BAF-4718-8FC3-6D9558F92656}" type="datetimeFigureOut">
               <a:rPr lang="en-US" smtClean="0"/>
-              <a:t>6/8/2026</a:t>
+              <a:t>6/10/2026</a:t>
             </a:fld>
             <a:endParaRPr lang="en-US"/>
           </a:p>
@@ -800,7 +800,7 @@
           <a:p>
             <a:fld id="{6D76A8BA-5FAE-4CF3-ACCC-95EC61FD0F15}" type="datetimeFigureOut">
               <a:rPr lang="en-US" smtClean="0"/>
-              <a:t>6/8/2026</a:t>
+              <a:t>6/10/2026</a:t>
             </a:fld>
             <a:endParaRPr lang="en-US"/>
           </a:p>
@@ -998,7 +998,7 @@
           <a:p>
             <a:fld id="{6D76A8BA-5FAE-4CF3-ACCC-95EC61FD0F15}" type="datetimeFigureOut">
               <a:rPr lang="en-US" smtClean="0"/>
-              <a:t>6/8/2026</a:t>
+              <a:t>6/10/2026</a:t>
             </a:fld>
             <a:endParaRPr lang="en-US"/>
           </a:p>
@@ -1206,7 +1206,7 @@
           <a:p>
             <a:fld id="{6D76A8BA-5FAE-4CF3-ACCC-95EC61FD0F15}" type="datetimeFigureOut">
               <a:rPr lang="en-US" smtClean="0"/>
-              <a:t>6/8/2026</a:t>
+              <a:t>6/10/2026</a:t>
             </a:fld>
             <a:endParaRPr lang="en-US"/>
           </a:p>
@@ -1404,7 +1404,7 @@
           <a:p>
             <a:fld id="{6D76A8BA-5FAE-4CF3-ACCC-95EC61FD0F15}" type="datetimeFigureOut">
               <a:rPr lang="en-US" smtClean="0"/>
-              <a:t>6/8/2026</a:t>
+              <a:t>6/10/2026</a:t>
             </a:fld>
             <a:endParaRPr lang="en-US"/>
           </a:p>
@@ -1679,7 +1679,7 @@
           <a:p>
             <a:fld id="{6D76A8BA-5FAE-4CF3-ACCC-95EC61FD0F15}" type="datetimeFigureOut">
               <a:rPr lang="en-US" smtClean="0"/>
-              <a:t>6/8/2026</a:t>
+              <a:t>6/10/2026</a:t>
             </a:fld>
             <a:endParaRPr lang="en-US"/>
           </a:p>
@@ -1944,7 +1944,7 @@
           <a:p>
             <a:fld id="{6D76A8BA-5FAE-4CF3-ACCC-95EC61FD0F15}" type="datetimeFigureOut">
               <a:rPr lang="en-US" smtClean="0"/>
-              <a:t>6/8/2026</a:t>
+              <a:t>6/10/2026</a:t>
             </a:fld>
             <a:endParaRPr lang="en-US"/>
           </a:p>
@@ -2356,7 +2356,7 @@
           <a:p>
             <a:fld id="{6D76A8BA-5FAE-4CF3-ACCC-95EC61FD0F15}" type="datetimeFigureOut">
               <a:rPr lang="en-US" smtClean="0"/>
-              <a:t>6/8/2026</a:t>
+              <a:t>6/10/2026</a:t>
             </a:fld>
             <a:endParaRPr lang="en-US"/>
           </a:p>
@@ -2497,7 +2497,7 @@
           <a:p>
             <a:fld id="{6D76A8BA-5FAE-4CF3-ACCC-95EC61FD0F15}" type="datetimeFigureOut">
               <a:rPr lang="en-US" smtClean="0"/>
-              <a:t>6/8/2026</a:t>
+              <a:t>6/10/2026</a:t>
             </a:fld>
             <a:endParaRPr lang="en-US"/>
           </a:p>
@@ -2610,7 +2610,7 @@
           <a:p>
             <a:fld id="{6D76A8BA-5FAE-4CF3-ACCC-95EC61FD0F15}" type="datetimeFigureOut">
               <a:rPr lang="en-US" smtClean="0"/>
-              <a:t>6/8/2026</a:t>
+              <a:t>6/10/2026</a:t>
             </a:fld>
             <a:endParaRPr lang="en-US"/>
           </a:p>
@@ -2921,7 +2921,7 @@
           <a:p>
             <a:fld id="{6D76A8BA-5FAE-4CF3-ACCC-95EC61FD0F15}" type="datetimeFigureOut">
               <a:rPr lang="en-US" smtClean="0"/>
-              <a:t>6/8/2026</a:t>
+              <a:t>6/10/2026</a:t>
             </a:fld>
             <a:endParaRPr lang="en-US"/>
           </a:p>
@@ -3209,7 +3209,7 @@
           <a:p>
             <a:fld id="{6D76A8BA-5FAE-4CF3-ACCC-95EC61FD0F15}" type="datetimeFigureOut">
               <a:rPr lang="en-US" smtClean="0"/>
-              <a:t>6/8/2026</a:t>
+              <a:t>6/10/2026</a:t>
             </a:fld>
             <a:endParaRPr lang="en-US"/>
           </a:p>
@@ -3450,7 +3450,7 @@
           <a:p>
             <a:fld id="{6D76A8BA-5FAE-4CF3-ACCC-95EC61FD0F15}" type="datetimeFigureOut">
               <a:rPr lang="en-US" smtClean="0"/>
-              <a:t>6/8/2026</a:t>
+              <a:t>6/10/2026</a:t>
             </a:fld>
             <a:endParaRPr lang="en-US"/>
           </a:p>
@@ -9911,7 +9911,7 @@
         </p:spPr>
         <p:txBody>
           <a:bodyPr>
-            <a:normAutofit/>
+            <a:normAutofit lnSpcReduction="10000"/>
           </a:bodyPr>
           <a:lstStyle/>
           <a:p>
@@ -9946,11 +9946,11 @@
             <a:pPr lvl="1"/>
             <a:r>
               <a:rPr lang="en-US" dirty="0"/>
-              <a:t>Not always the same approach has been predominant</a:t>
-            </a:r>
-          </a:p>
-          <a:p>
-            <a:endParaRPr lang="en-US" sz="2800" dirty="0"/>
+              <a:t>Not always the same approach has been predominant when analyzing mortality changes</a:t>
+            </a:r>
+          </a:p>
+          <a:p>
+            <a:endParaRPr lang="en-US" sz="1000" dirty="0"/>
           </a:p>
           <a:p>
             <a:r>
@@ -10710,7 +10710,15 @@
           <a:p>
             <a:r>
               <a:rPr lang="en-US" sz="3000" dirty="0"/>
-              <a:t>Mortality change as a demographic metabolism process</a:t>
+              <a:t>Mortality change as a </a:t>
+            </a:r>
+            <a:r>
+              <a:rPr lang="en-US" sz="3000" i="1" dirty="0"/>
+              <a:t>demographic metabolism</a:t>
+            </a:r>
+            <a:r>
+              <a:rPr lang="en-US" sz="3000" dirty="0"/>
+              <a:t> process</a:t>
             </a:r>
           </a:p>
           <a:p>

</xml_diff>